<commit_message>
Batch 1 folder added and codes moved
</commit_message>
<xml_diff>
--- a/Presentations/AVR Live Class 6.pptx
+++ b/Presentations/AVR Live Class 6.pptx
@@ -296,52 +296,22 @@
   <pc:docChgLst>
     <pc:chgData name="Sreejith Rajan" userId="ec11bca0e4bee75f" providerId="LiveId" clId="{7B4F392D-EAB3-4CE7-903E-F84869825F47}"/>
     <pc:docChg chg="undo custSel addSld delSld modSld sldOrd">
-      <pc:chgData name="Sreejith Rajan" userId="ec11bca0e4bee75f" providerId="LiveId" clId="{7B4F392D-EAB3-4CE7-903E-F84869825F47}" dt="2025-11-27T14:57:36.436" v="824" actId="1076"/>
+      <pc:chgData name="Sreejith Rajan" userId="ec11bca0e4bee75f" providerId="LiveId" clId="{7B4F392D-EAB3-4CE7-903E-F84869825F47}" dt="2026-02-03T16:46:40.760" v="826" actId="20577"/>
       <pc:docMkLst>
         <pc:docMk/>
       </pc:docMkLst>
       <pc:sldChg chg="modSp mod">
-        <pc:chgData name="Sreejith Rajan" userId="ec11bca0e4bee75f" providerId="LiveId" clId="{7B4F392D-EAB3-4CE7-903E-F84869825F47}" dt="2025-11-27T14:57:36.436" v="824" actId="1076"/>
+        <pc:chgData name="Sreejith Rajan" userId="ec11bca0e4bee75f" providerId="LiveId" clId="{7B4F392D-EAB3-4CE7-903E-F84869825F47}" dt="2026-02-03T16:46:40.760" v="826" actId="20577"/>
         <pc:sldMkLst>
           <pc:docMk/>
-          <pc:sldMk cId="1389626550" sldId="267"/>
-        </pc:sldMkLst>
-        <pc:picChg chg="mod">
-          <ac:chgData name="Sreejith Rajan" userId="ec11bca0e4bee75f" providerId="LiveId" clId="{7B4F392D-EAB3-4CE7-903E-F84869825F47}" dt="2025-11-27T14:57:36.436" v="824" actId="1076"/>
-          <ac:picMkLst>
-            <pc:docMk/>
-            <pc:sldMk cId="1389626550" sldId="267"/>
-            <ac:picMk id="4" creationId="{C49C1DF3-C6D7-3FBE-C7BE-60CD0077F615}"/>
-          </ac:picMkLst>
-        </pc:picChg>
-      </pc:sldChg>
-      <pc:sldChg chg="delSp modSp mod">
-        <pc:chgData name="Sreejith Rajan" userId="ec11bca0e4bee75f" providerId="LiveId" clId="{7B4F392D-EAB3-4CE7-903E-F84869825F47}" dt="2025-11-25T13:50:35.880" v="537" actId="1076"/>
-        <pc:sldMkLst>
-          <pc:docMk/>
-          <pc:sldMk cId="2517281589" sldId="274"/>
+          <pc:sldMk cId="1380718396" sldId="289"/>
         </pc:sldMkLst>
         <pc:spChg chg="mod">
-          <ac:chgData name="Sreejith Rajan" userId="ec11bca0e4bee75f" providerId="LiveId" clId="{7B4F392D-EAB3-4CE7-903E-F84869825F47}" dt="2025-11-25T13:50:35.880" v="537" actId="1076"/>
+          <ac:chgData name="Sreejith Rajan" userId="ec11bca0e4bee75f" providerId="LiveId" clId="{7B4F392D-EAB3-4CE7-903E-F84869825F47}" dt="2026-02-03T16:46:40.760" v="826" actId="20577"/>
           <ac:spMkLst>
             <pc:docMk/>
-            <pc:sldMk cId="2517281589" sldId="274"/>
-            <ac:spMk id="54" creationId="{F5C408E8-BC47-B2C2-7462-C129AFFB4F4F}"/>
-          </ac:spMkLst>
-        </pc:spChg>
-      </pc:sldChg>
-      <pc:sldChg chg="addSp delSp modSp add mod">
-        <pc:chgData name="Sreejith Rajan" userId="ec11bca0e4bee75f" providerId="LiveId" clId="{7B4F392D-EAB3-4CE7-903E-F84869825F47}" dt="2025-11-25T15:36:41.492" v="822" actId="12"/>
-        <pc:sldMkLst>
-          <pc:docMk/>
-          <pc:sldMk cId="1559068308" sldId="290"/>
-        </pc:sldMkLst>
-        <pc:spChg chg="mod">
-          <ac:chgData name="Sreejith Rajan" userId="ec11bca0e4bee75f" providerId="LiveId" clId="{7B4F392D-EAB3-4CE7-903E-F84869825F47}" dt="2025-11-25T15:36:41.492" v="822" actId="12"/>
-          <ac:spMkLst>
-            <pc:docMk/>
-            <pc:sldMk cId="1559068308" sldId="290"/>
-            <ac:spMk id="54" creationId="{68629363-375B-DB57-5488-0DDA54605AC4}"/>
+            <pc:sldMk cId="1380718396" sldId="289"/>
+            <ac:spMk id="55" creationId="{D02D7CAE-38F8-8545-FFF6-1F577A01BE56}"/>
           </ac:spMkLst>
         </pc:spChg>
       </pc:sldChg>

</xml_diff>